<commit_message>
Polish curated demo typography
</commit_message>
<xml_diff>
--- a/examples/pptrans-demo.zh-CN.pptx
+++ b/examples/pptrans-demo.zh-CN.pptx
@@ -1365,7 +1365,7 @@
                 <a:ea typeface="Arial"/>
                 <a:cs typeface="Arial"/>
               </a:rPr>
-              <a:t>PPTrans 仅修改计划内文本节点，验证 OOXML 包，且绝不覆盖源演示文稿。</a:t>
+              <a:t>PPTrans 只改目标文本，验证 OOXML，绝不覆盖源文稿。</a:t>
             </a:r>
           </a:p>
         </p:txBody>
@@ -1745,7 +1745,7 @@
                   <a:srgbClr val="5F6672"/>
                 </a:solidFill>
               </a:rPr>
-              <a:t>稳定的形状 ID 与源哈希定位每个可编辑文本片段。</a:t>
+              <a:t>形状 ID 与源哈希定位可编辑文本。</a:t>
             </a:r>
           </a:p>
         </p:txBody>
@@ -1981,7 +1981,7 @@
                   <a:srgbClr val="5F6672"/>
                 </a:solidFill>
               </a:rPr>
-              <a:t>输出原子发布前，只允许修改计划内文本节点。</a:t>
+              <a:t>发布前，只改目标文本。</a:t>
             </a:r>
           </a:p>
         </p:txBody>

</xml_diff>